<commit_message>
Partner Mode: guest account and My wines; no wider trends promised
- Favourites are saved under My wines in the guest's email-identified
  account (founder, 12 October).
- Wider trends removed from the Partner Mode pack: whether they're
  offered depends on the build. Recorded in the Brand Brain (PROPOSED).

Co-Authored-By: Claude Opus 5.5 <noreply@anthropic.com>
Claude-Session: https://claude.ai/code/session_012JYWa7EuArd2TznyfiWkZR
</commit_message>
<xml_diff>
--- a/decks/Entre Amis - Partner Mode pack - DRAFT.pptx
+++ b/decks/Entre Amis - Partner Mode pack - DRAFT.pptx
@@ -120,13 +120,13 @@
   <p:extLst>
     <p:ext uri="{521415D9-36F7-43E2-AB2F-B90AF26B5E84}">
       <p14:sectionLst xmlns:p14="http://schemas.microsoft.com/office/powerpoint/2010/main">
-        <p14:section name="Introduction" id="{e0f49310-f7e0-19f7-63bb-2b27c74df7b1}">
+        <p14:section name="Introduction" id="{a0469af0-4843-fe55-0ef8-9caba5f140ca}">
           <p14:sldIdLst>
             <p14:sldId id="256"/>
             <p14:sldId id="257"/>
           </p14:sldIdLst>
         </p14:section>
-        <p14:section name="Partner Mode" id="{d96c5f4e-137d-f91b-c8de-ab0743f4e3af}">
+        <p14:section name="Partner Mode" id="{6ad78e53-0c5e-26b6-fac2-d30847efc3a0}">
           <p14:sldIdLst>
             <p14:sldId id="258"/>
             <p14:sldId id="259"/>
@@ -136,20 +136,20 @@
             <p14:sldId id="263"/>
           </p14:sldIdLst>
         </p14:section>
-        <p14:section name="Working together" id="{81fb1c00-358b-1523-1856-f93d411c1cd1}">
+        <p14:section name="Working together" id="{7dc1e917-1860-db75-83ee-78cd2e0d16b7}">
           <p14:sldIdLst>
             <p14:sldId id="264"/>
             <p14:sldId id="265"/>
           </p14:sldIdLst>
         </p14:section>
-        <p14:section name="About us" id="{588a1979-2136-3ecc-0991-3fb53d88a7eb}">
+        <p14:section name="About us" id="{844f43a4-82f0-768f-855d-836ad7069c6b}">
           <p14:sldIdLst>
             <p14:sldId id="266"/>
             <p14:sldId id="267"/>
             <p14:sldId id="268"/>
           </p14:sldIdLst>
         </p14:section>
-        <p14:section name="Working notes — delete before sharing" id="{048a118a-d675-8e05-e556-7d2353cd975b}">
+        <p14:section name="Working notes — delete before sharing" id="{cdf0ef9f-056e-2bd8-82f4-9c9f04d8290a}">
           <p14:sldIdLst>
             <p14:sldId id="269"/>
           </p14:sldIdLst>
@@ -1526,7 +1526,7 @@
           <a:p>
             <a:r>
               <a:rPr lang="en-US" dirty="0"/>
-              <a:t>In Partner Mode, contacts go to that one host only (proposed, Brand Brain 03).</a:t>
+              <a:t>In Partner Mode, contacts go to that one host only (proposed, Brand Brain 03). Wider Entre Amis trends are not promised in Partner Mode: they depend on how it is built (founder, 12 October).</a:t>
             </a:r>
             <a:endParaRPr lang="en-US" dirty="0"/>
           </a:p>
@@ -4931,43 +4931,7 @@
                   <a:schemeClr val="tx1"/>
                 </a:solidFill>
               </a:rPr>
-              <a:t>'Profile' means Wine 101 (slide 4)</a:t>
-            </a:r>
-            <a:endParaRPr lang="en-US" sz="1400" dirty="0"/>
-          </a:p>
-          <a:p>
-            <a:pPr marL="203200" indent="-203200">
-              <a:spcAft>
-                <a:spcPts val="600"/>
-              </a:spcAft>
-              <a:buSzPct val="100000"/>
-              <a:buChar char="•"/>
-            </a:pPr>
-            <a:r>
-              <a:rPr lang="en-US" sz="1400" dirty="0">
-                <a:solidFill>
-                  <a:schemeClr val="tx1"/>
-                </a:solidFill>
-              </a:rPr>
               <a:t>Contacts rule, legal review (slides 5, 7)</a:t>
-            </a:r>
-            <a:endParaRPr lang="en-US" sz="1400" dirty="0"/>
-          </a:p>
-          <a:p>
-            <a:pPr marL="203200" indent="-203200">
-              <a:spcAft>
-                <a:spcPts val="600"/>
-              </a:spcAft>
-              <a:buSzPct val="100000"/>
-              <a:buChar char="•"/>
-            </a:pPr>
-            <a:r>
-              <a:rPr lang="en-US" sz="1400" dirty="0">
-                <a:solidFill>
-                  <a:schemeClr val="tx1"/>
-                </a:solidFill>
-              </a:rPr>
-              <a:t>Wider trends in Partner Mode? (slide 7)</a:t>
             </a:r>
             <a:endParaRPr lang="en-US" sz="1400" dirty="0"/>
           </a:p>
@@ -7378,7 +7342,7 @@
                   <a:schemeClr val="tx1"/>
                 </a:solidFill>
               </a:rPr>
-              <a:t>Favourites are stored in their profile. Notes are theirs to keep or share.</a:t>
+              <a:t>Favourites are saved under My wines in their account. Notes are theirs to keep or share.</a:t>
             </a:r>
             <a:endParaRPr lang="en-US" sz="1400" dirty="0"/>
           </a:p>
@@ -7393,7 +7357,7 @@
         <p:spPr>
           <a:xfrm>
             <a:off x="548640" y="4937760"/>
-            <a:ext cx="5410048" cy="914400"/>
+            <a:ext cx="11094415" cy="640080"/>
           </a:xfrm>
           <a:prstGeom prst="rect">
             <a:avLst/>
@@ -7435,62 +7399,6 @@
                 </a:solidFill>
               </a:rPr>
               <a:t>Quizzes are framed as learning about you: answers revealed as discoveries, nobody told they were wrong.</a:t>
-            </a:r>
-            <a:endParaRPr lang="en-US" sz="1100" dirty="0"/>
-          </a:p>
-        </p:txBody>
-      </p:sp>
-      <p:sp>
-        <p:nvSpPr>
-          <p:cNvPr id="25" name="FLAG — delete before sharing"/>
-          <p:cNvSpPr txBox="1"/>
-          <p:nvPr/>
-        </p:nvSpPr>
-        <p:spPr>
-          <a:xfrm>
-            <a:off x="6233008" y="4937760"/>
-            <a:ext cx="5410048" cy="914400"/>
-          </a:xfrm>
-          <a:prstGeom prst="rect">
-            <a:avLst/>
-          </a:prstGeom>
-          <a:solidFill>
-            <a:schemeClr val="bg1"/>
-          </a:solidFill>
-          <a:ln w="25400">
-            <a:solidFill>
-              <a:schemeClr val="accent4"/>
-            </a:solidFill>
-          </a:ln>
-        </p:spPr>
-        <p:txBody>
-          <a:bodyPr wrap="square" lIns="38100" tIns="76200" rIns="76200" bIns="38100" rtlCol="0" anchor="ctr"/>
-          <a:lstStyle/>
-          <a:p>
-            <a:pPr indent="0" marL="0">
-              <a:buNone/>
-            </a:pPr>
-            <a:r>
-              <a:rPr lang="en-US" sz="1100" dirty="0">
-                <a:solidFill>
-                  <a:schemeClr val="tx1"/>
-                </a:solidFill>
-                <a:latin typeface="Raleway SemiBold" pitchFamily="34" charset="0"/>
-                <a:ea typeface="Raleway SemiBold" pitchFamily="34" charset="-122"/>
-                <a:cs typeface="Raleway SemiBold" pitchFamily="34" charset="-120"/>
-              </a:rPr>
-              <a:t>TO CONFIRM  </a:t>
-            </a:r>
-            <a:pPr indent="0" marL="0">
-              <a:buNone/>
-            </a:pPr>
-            <a:r>
-              <a:rPr lang="en-US" sz="1100" dirty="0">
-                <a:solidFill>
-                  <a:schemeClr val="tx1"/>
-                </a:solidFill>
-              </a:rPr>
-              <a:t>'Profile' means Wine 101, the personal wine library in the app.</a:t>
             </a:r>
             <a:endParaRPr lang="en-US" sz="1100" dirty="0"/>
           </a:p>
@@ -7871,7 +7779,7 @@
                   <a:schemeClr val="tx1"/>
                 </a:solidFill>
               </a:rPr>
-              <a:t>Their favourite wines, stored for later.</a:t>
+              <a:t>Their favourite wines, saved under My wines.</a:t>
             </a:r>
             <a:endParaRPr lang="en-US" sz="1600" dirty="0"/>
           </a:p>
@@ -9024,7 +8932,7 @@
                 <a:ea typeface="Raleway Light" pitchFamily="34" charset="-122"/>
                 <a:cs typeface="Raleway Light" pitchFamily="34" charset="-120"/>
               </a:rPr>
-              <a:t>All built on consent.</a:t>
+              <a:t>Two layers, both built on consent.</a:t>
             </a:r>
             <a:endParaRPr lang="en-US" sz="1800" dirty="0"/>
           </a:p>
@@ -9387,170 +9295,14 @@
       </p:sp>
       <p:sp>
         <p:nvSpPr>
-          <p:cNvPr id="13" name="Layer: Wider trends"/>
-          <p:cNvSpPr/>
-          <p:nvPr/>
-        </p:nvSpPr>
-        <p:spPr>
-          <a:xfrm>
-            <a:off x="548640" y="3977640"/>
-            <a:ext cx="11094415" cy="960120"/>
-          </a:xfrm>
-          <a:prstGeom prst="roundRect">
-            <a:avLst>
-              <a:gd name="adj" fmla="val 11429"/>
-            </a:avLst>
-          </a:prstGeom>
-          <a:solidFill>
-            <a:schemeClr val="bg1"/>
-          </a:solidFill>
-          <a:ln w="12700">
-            <a:solidFill>
-              <a:schemeClr val="bg1"/>
-            </a:solidFill>
-            <a:prstDash val="solid"/>
-          </a:ln>
-          <a:effectLst>
-            <a:outerShdw sx="100000" sy="100000" kx="0" ky="0" algn="bl" rotWithShape="0" blurRad="76200" dist="25400" dir="5400000">
-              <a:srgbClr val="565A32">
-                <a:alpha val="12000"/>
-              </a:srgbClr>
-            </a:outerShdw>
-          </a:effectLst>
-        </p:spPr>
-      </p:sp>
-      <p:sp>
-        <p:nvSpPr>
-          <p:cNvPr id="14" name="Text 12"/>
+          <p:cNvPr id="13" name="FLAG — delete before sharing"/>
           <p:cNvSpPr txBox="1"/>
           <p:nvPr/>
         </p:nvSpPr>
         <p:spPr>
           <a:xfrm>
-            <a:off x="822960" y="4160520"/>
-            <a:ext cx="594360" cy="594360"/>
-          </a:xfrm>
-          <a:prstGeom prst="ellipse">
-            <a:avLst/>
-          </a:prstGeom>
-          <a:solidFill>
-            <a:schemeClr val="tx1"/>
-          </a:solidFill>
-          <a:ln/>
-        </p:spPr>
-        <p:txBody>
-          <a:bodyPr wrap="square" lIns="0" tIns="0" rIns="0" bIns="0" rtlCol="0" anchor="ctr"/>
-          <a:lstStyle/>
-          <a:p>
-            <a:pPr algn="ctr" indent="0" marL="0">
-              <a:buNone/>
-            </a:pPr>
-            <a:r>
-              <a:rPr lang="en-US" sz="1600" dirty="0">
-                <a:solidFill>
-                  <a:schemeClr val="bg2"/>
-                </a:solidFill>
-                <a:latin typeface="Raleway SemiBold" pitchFamily="34" charset="0"/>
-                <a:ea typeface="Raleway SemiBold" pitchFamily="34" charset="-122"/>
-                <a:cs typeface="Raleway SemiBold" pitchFamily="34" charset="-120"/>
-              </a:rPr>
-              <a:t>3</a:t>
-            </a:r>
-            <a:endParaRPr lang="en-US" sz="1600" dirty="0"/>
-          </a:p>
-        </p:txBody>
-      </p:sp>
-      <p:sp>
-        <p:nvSpPr>
-          <p:cNvPr id="15" name="Text 13"/>
-          <p:cNvSpPr txBox="1"/>
-          <p:nvPr/>
-        </p:nvSpPr>
-        <p:spPr>
-          <a:xfrm>
-            <a:off x="1691640" y="3977640"/>
-            <a:ext cx="2651760" cy="960120"/>
-          </a:xfrm>
-          <a:prstGeom prst="rect">
-            <a:avLst/>
-          </a:prstGeom>
-          <a:noFill/>
-          <a:ln/>
-        </p:spPr>
-        <p:txBody>
-          <a:bodyPr wrap="square" lIns="0" tIns="0" rIns="0" bIns="0" rtlCol="0" anchor="ctr"/>
-          <a:lstStyle/>
-          <a:p>
-            <a:pPr indent="0" marL="0">
-              <a:spcAft>
-                <a:spcPts val="400"/>
-              </a:spcAft>
-              <a:buNone/>
-            </a:pPr>
-            <a:r>
-              <a:rPr lang="en-US" sz="1600" dirty="0">
-                <a:solidFill>
-                  <a:schemeClr val="tx1"/>
-                </a:solidFill>
-                <a:latin typeface="Raleway SemiBold" pitchFamily="34" charset="0"/>
-                <a:ea typeface="Raleway SemiBold" pitchFamily="34" charset="-122"/>
-                <a:cs typeface="Raleway SemiBold" pitchFamily="34" charset="-120"/>
-              </a:rPr>
-              <a:t>Wider trends</a:t>
-            </a:r>
-            <a:endParaRPr lang="en-US" sz="1600" dirty="0"/>
-          </a:p>
-        </p:txBody>
-      </p:sp>
-      <p:sp>
-        <p:nvSpPr>
-          <p:cNvPr id="16" name="Text 14"/>
-          <p:cNvSpPr txBox="1"/>
-          <p:nvPr/>
-        </p:nvSpPr>
-        <p:spPr>
-          <a:xfrm>
-            <a:off x="4389120" y="3977640"/>
-            <a:ext cx="6979615" cy="960120"/>
-          </a:xfrm>
-          <a:prstGeom prst="rect">
-            <a:avLst/>
-          </a:prstGeom>
-          <a:noFill/>
-          <a:ln/>
-        </p:spPr>
-        <p:txBody>
-          <a:bodyPr wrap="square" lIns="0" tIns="0" rIns="0" bIns="0" rtlCol="0" anchor="ctr"/>
-          <a:lstStyle/>
-          <a:p>
-            <a:pPr indent="0" marL="0">
-              <a:spcAft>
-                <a:spcPts val="400"/>
-              </a:spcAft>
-              <a:buNone/>
-            </a:pPr>
-            <a:r>
-              <a:rPr lang="en-US" sz="1600" dirty="0">
-                <a:solidFill>
-                  <a:schemeClr val="tx1"/>
-                </a:solidFill>
-              </a:rPr>
-              <a:t>Carefully anonymised Entre Amis trends, where numbers and permissions allow.</a:t>
-            </a:r>
-            <a:endParaRPr lang="en-US" sz="1600" dirty="0"/>
-          </a:p>
-        </p:txBody>
-      </p:sp>
-      <p:sp>
-        <p:nvSpPr>
-          <p:cNvPr id="17" name="FLAG — delete before sharing"/>
-          <p:cNvSpPr txBox="1"/>
-          <p:nvPr/>
-        </p:nvSpPr>
-        <p:spPr>
-          <a:xfrm>
-            <a:off x="548640" y="5166360"/>
-            <a:ext cx="5410048" cy="731520"/>
+            <a:off x="548640" y="4069080"/>
+            <a:ext cx="11094415" cy="548640"/>
           </a:xfrm>
           <a:prstGeom prst="rect">
             <a:avLst/>
@@ -9599,36 +9351,60 @@
       </p:sp>
       <p:sp>
         <p:nvSpPr>
-          <p:cNvPr id="18" name="FLAG — delete before sharing"/>
+          <p:cNvPr id="14" name="Image placeholder"/>
+          <p:cNvSpPr/>
+          <p:nvPr/>
+        </p:nvSpPr>
+        <p:spPr>
+          <a:xfrm>
+            <a:off x="548640" y="4800600"/>
+            <a:ext cx="11094415" cy="1143000"/>
+          </a:xfrm>
+          <a:prstGeom prst="roundRect">
+            <a:avLst>
+              <a:gd name="adj" fmla="val 9600"/>
+            </a:avLst>
+          </a:prstGeom>
+          <a:solidFill>
+            <a:schemeClr val="accent3"/>
+          </a:solidFill>
+          <a:ln w="12700">
+            <a:solidFill>
+              <a:schemeClr val="tx1"/>
+            </a:solidFill>
+            <a:prstDash val="dash"/>
+          </a:ln>
+        </p:spPr>
+      </p:sp>
+      <p:sp>
+        <p:nvSpPr>
+          <p:cNvPr id="15" name="Text 13"/>
           <p:cNvSpPr txBox="1"/>
           <p:nvPr/>
         </p:nvSpPr>
         <p:spPr>
           <a:xfrm>
-            <a:off x="6233008" y="5166360"/>
-            <a:ext cx="5410048" cy="731520"/>
-          </a:xfrm>
-          <a:prstGeom prst="rect">
-            <a:avLst/>
-          </a:prstGeom>
-          <a:solidFill>
-            <a:schemeClr val="bg1"/>
-          </a:solidFill>
-          <a:ln w="25400">
-            <a:solidFill>
-              <a:schemeClr val="accent4"/>
-            </a:solidFill>
-          </a:ln>
-        </p:spPr>
-        <p:txBody>
-          <a:bodyPr wrap="square" lIns="38100" tIns="76200" rIns="76200" bIns="38100" rtlCol="0" anchor="ctr"/>
-          <a:lstStyle/>
-          <a:p>
-            <a:pPr indent="0" marL="0">
-              <a:buNone/>
-            </a:pPr>
-            <a:r>
-              <a:rPr lang="en-US" sz="1100" dirty="0">
+            <a:off x="822960" y="4800600"/>
+            <a:ext cx="10545775" cy="1143000"/>
+          </a:xfrm>
+          <a:prstGeom prst="rect">
+            <a:avLst/>
+          </a:prstGeom>
+          <a:noFill/>
+          <a:ln/>
+        </p:spPr>
+        <p:txBody>
+          <a:bodyPr wrap="square" lIns="0" tIns="0" rIns="0" bIns="0" rtlCol="0" anchor="ctr"/>
+          <a:lstStyle/>
+          <a:p>
+            <a:pPr algn="ctr" indent="0" marL="0">
+              <a:spcAft>
+                <a:spcPts val="400"/>
+              </a:spcAft>
+              <a:buNone/>
+            </a:pPr>
+            <a:r>
+              <a:rPr lang="en-US" sz="1400" dirty="0">
                 <a:solidFill>
                   <a:schemeClr val="tx1"/>
                 </a:solidFill>
@@ -9636,20 +9412,9 @@
                 <a:ea typeface="Raleway SemiBold" pitchFamily="34" charset="-122"/>
                 <a:cs typeface="Raleway SemiBold" pitchFamily="34" charset="-120"/>
               </a:rPr>
-              <a:t>TO DECIDE  </a:t>
-            </a:r>
-            <a:pPr indent="0" marL="0">
-              <a:buNone/>
-            </a:pPr>
-            <a:r>
-              <a:rPr lang="en-US" sz="1100" dirty="0">
-                <a:solidFill>
-                  <a:schemeClr val="tx1"/>
-                </a:solidFill>
-              </a:rPr>
-              <a:t>Is wider trends offered in Partner Mode, or Event Mode only?</a:t>
-            </a:r>
-            <a:endParaRPr lang="en-US" sz="1100" dirty="0"/>
+              <a:t>Example insight report — to add</a:t>
+            </a:r>
+            <a:endParaRPr lang="en-US" sz="1400" dirty="0"/>
           </a:p>
         </p:txBody>
       </p:sp>

</xml_diff>